<commit_message>
Full remaster - rebuilt all 6 slides from scratch, cleaner code, better animations
</commit_message>
<xml_diff>
--- a/presentation.pptx
+++ b/presentation.pptx
@@ -3089,7 +3089,7 @@
     <p:bg>
       <p:bgPr>
         <a:solidFill>
-          <a:srgbClr val="0A0A0A"/>
+          <a:srgbClr val="050505"/>
         </a:solidFill>
         <a:effectLst/>
       </p:bgPr>
@@ -3109,16 +3109,16 @@
         </p:nvSpPr>
         <p:spPr>
           <a:xfrm>
-            <a:off x="10789920" y="274320"/>
-            <a:ext cx="1097280" cy="1097280"/>
+            <a:off x="10881360" y="274320"/>
+            <a:ext cx="1005840" cy="1005840"/>
           </a:xfrm>
           <a:prstGeom prst="ellipse">
             <a:avLst/>
           </a:prstGeom>
           <a:solidFill>
-            <a:srgbClr val="0A0A0A"/>
+            <a:srgbClr val="050505"/>
           </a:solidFill>
-          <a:ln w="38100">
+          <a:ln w="25400">
             <a:solidFill>
               <a:srgbClr val="00FF00"/>
             </a:solidFill>
@@ -3143,7 +3143,7 @@
           <a:lstStyle/>
           <a:p>
             <a:pPr algn="ctr">
-              <a:defRPr sz="2800" b="1">
+              <a:defRPr sz="2600" b="1">
                 <a:solidFill>
                   <a:srgbClr val="00FF00"/>
                 </a:solidFill>
@@ -3163,8 +3163,8 @@
         </p:nvSpPr>
         <p:spPr>
           <a:xfrm>
-            <a:off x="10789920" y="1417320"/>
-            <a:ext cx="1097280" cy="274320"/>
+            <a:off x="10881360" y="1325880"/>
+            <a:ext cx="1005840" cy="274320"/>
           </a:xfrm>
           <a:prstGeom prst="rect">
             <a:avLst/>
@@ -3178,7 +3178,7 @@
           <a:lstStyle/>
           <a:p>
             <a:pPr algn="ctr">
-              <a:defRPr sz="800">
+              <a:defRPr sz="700">
                 <a:solidFill>
                   <a:srgbClr val="00FF00"/>
                 </a:solidFill>
@@ -3233,8 +3233,8 @@
         </p:nvSpPr>
         <p:spPr>
           <a:xfrm>
-            <a:off x="914400" y="2286000"/>
-            <a:ext cx="10362895" cy="1371600"/>
+            <a:off x="914400" y="2011680"/>
+            <a:ext cx="10332720" cy="1371600"/>
           </a:xfrm>
           <a:prstGeom prst="rect">
             <a:avLst/>
@@ -3248,7 +3248,7 @@
           <a:lstStyle/>
           <a:p>
             <a:pPr algn="ctr">
-              <a:defRPr sz="8000" b="1">
+              <a:defRPr sz="7200" b="1">
                 <a:solidFill>
                   <a:srgbClr val="00FF00"/>
                 </a:solidFill>
@@ -3269,8 +3269,8 @@
         </p:nvSpPr>
         <p:spPr>
           <a:xfrm>
-            <a:off x="914400" y="4114800"/>
-            <a:ext cx="10362895" cy="1371600"/>
+            <a:off x="914400" y="3840480"/>
+            <a:ext cx="10332720" cy="1371600"/>
           </a:xfrm>
           <a:prstGeom prst="rect">
             <a:avLst/>
@@ -3284,9 +3284,9 @@
           <a:lstStyle/>
           <a:p>
             <a:pPr algn="ctr">
-              <a:defRPr sz="3600" b="1">
-                <a:solidFill>
-                  <a:srgbClr val="00FF00"/>
+              <a:defRPr sz="3200" b="1">
+                <a:solidFill>
+                  <a:srgbClr val="00FFFF"/>
                 </a:solidFill>
                 <a:latin typeface="Courier New"/>
               </a:defRPr>
@@ -3305,8 +3305,8 @@
         </p:nvSpPr>
         <p:spPr>
           <a:xfrm>
-            <a:off x="914400" y="5029200"/>
-            <a:ext cx="10362895" cy="1371600"/>
+            <a:off x="914400" y="4846320"/>
+            <a:ext cx="10332720" cy="1371600"/>
           </a:xfrm>
           <a:prstGeom prst="rect">
             <a:avLst/>
@@ -3320,7 +3320,7 @@
           <a:lstStyle/>
           <a:p>
             <a:pPr algn="ctr">
-              <a:defRPr sz="2400" b="1">
+              <a:defRPr sz="2000" b="1">
                 <a:solidFill>
                   <a:srgbClr val="333333"/>
                 </a:solidFill>
@@ -3348,7 +3348,7 @@
     <p:bg>
       <p:bgPr>
         <a:solidFill>
-          <a:srgbClr val="0A0A0A"/>
+          <a:srgbClr val="050505"/>
         </a:solidFill>
         <a:effectLst/>
       </p:bgPr>
@@ -3368,16 +3368,16 @@
         </p:nvSpPr>
         <p:spPr>
           <a:xfrm>
-            <a:off x="10789920" y="274320"/>
-            <a:ext cx="1097280" cy="1097280"/>
+            <a:off x="10881360" y="274320"/>
+            <a:ext cx="1005840" cy="1005840"/>
           </a:xfrm>
           <a:prstGeom prst="ellipse">
             <a:avLst/>
           </a:prstGeom>
           <a:solidFill>
-            <a:srgbClr val="0A0A0A"/>
+            <a:srgbClr val="050505"/>
           </a:solidFill>
-          <a:ln w="38100">
+          <a:ln w="25400">
             <a:solidFill>
               <a:srgbClr val="00FF00"/>
             </a:solidFill>
@@ -3402,7 +3402,7 @@
           <a:lstStyle/>
           <a:p>
             <a:pPr algn="ctr">
-              <a:defRPr sz="2800" b="1">
+              <a:defRPr sz="2600" b="1">
                 <a:solidFill>
                   <a:srgbClr val="00FF00"/>
                 </a:solidFill>
@@ -3422,8 +3422,8 @@
         </p:nvSpPr>
         <p:spPr>
           <a:xfrm>
-            <a:off x="10789920" y="1417320"/>
-            <a:ext cx="1097280" cy="274320"/>
+            <a:off x="10881360" y="1325880"/>
+            <a:ext cx="1005840" cy="274320"/>
           </a:xfrm>
           <a:prstGeom prst="rect">
             <a:avLst/>
@@ -3437,7 +3437,7 @@
           <a:lstStyle/>
           <a:p>
             <a:pPr algn="ctr">
-              <a:defRPr sz="800">
+              <a:defRPr sz="700">
                 <a:solidFill>
                   <a:srgbClr val="00FF00"/>
                 </a:solidFill>
@@ -3492,8 +3492,8 @@
         </p:nvSpPr>
         <p:spPr>
           <a:xfrm>
-            <a:off x="1371600" y="1828800"/>
-            <a:ext cx="3657600" cy="2743200"/>
+            <a:off x="914400" y="1645920"/>
+            <a:ext cx="4572000" cy="2286000"/>
           </a:xfrm>
           <a:prstGeom prst="rect">
             <a:avLst/>
@@ -3507,7 +3507,7 @@
           <a:lstStyle/>
           <a:p>
             <a:pPr algn="ctr">
-              <a:defRPr sz="4000" b="1">
+              <a:defRPr sz="3600" b="1">
                 <a:solidFill>
                   <a:srgbClr val="00FF00"/>
                 </a:solidFill>
@@ -3520,7 +3520,7 @@
           </a:p>
           <a:p>
             <a:pPr algn="ctr">
-              <a:defRPr sz="1400">
+              <a:defRPr sz="1200">
                 <a:solidFill>
                   <a:srgbClr val="00FF00"/>
                 </a:solidFill>
@@ -3540,8 +3540,8 @@
         </p:nvSpPr>
         <p:spPr>
           <a:xfrm>
-            <a:off x="6858000" y="1828800"/>
-            <a:ext cx="3657600" cy="2743200"/>
+            <a:off x="6675120" y="1645920"/>
+            <a:ext cx="4572000" cy="2286000"/>
           </a:xfrm>
           <a:prstGeom prst="rect">
             <a:avLst/>
@@ -3555,7 +3555,7 @@
           <a:lstStyle/>
           <a:p>
             <a:pPr algn="ctr">
-              <a:defRPr sz="4000" b="1">
+              <a:defRPr sz="3600" b="1">
                 <a:solidFill>
                   <a:srgbClr val="FF0000"/>
                 </a:solidFill>
@@ -3568,7 +3568,7 @@
           </a:p>
           <a:p>
             <a:pPr algn="ctr">
-              <a:defRPr sz="1400">
+              <a:defRPr sz="1200">
                 <a:solidFill>
                   <a:srgbClr val="FF0000"/>
                 </a:solidFill>
@@ -3588,8 +3588,8 @@
         </p:nvSpPr>
         <p:spPr>
           <a:xfrm>
-            <a:off x="914400" y="5029200"/>
-            <a:ext cx="10362895" cy="1371600"/>
+            <a:off x="914400" y="2560320"/>
+            <a:ext cx="10332720" cy="1371600"/>
           </a:xfrm>
           <a:prstGeom prst="rect">
             <a:avLst/>
@@ -3603,7 +3603,43 @@
           <a:lstStyle/>
           <a:p>
             <a:pPr algn="ctr">
-              <a:defRPr sz="4800" b="1">
+              <a:defRPr sz="1600" b="1">
+                <a:solidFill>
+                  <a:srgbClr val="555555"/>
+                </a:solidFill>
+                <a:latin typeface="Courier New"/>
+              </a:defRPr>
+            </a:pPr>
+            <a:r>
+              <a:t>VS</a:t>
+            </a:r>
+          </a:p>
+        </p:txBody>
+      </p:sp>
+      <p:sp>
+        <p:nvSpPr>
+          <p:cNvPr id="8" name="TextBox 7"/>
+          <p:cNvSpPr txBox="1"/>
+          <p:nvPr/>
+        </p:nvSpPr>
+        <p:spPr>
+          <a:xfrm>
+            <a:off x="914400" y="4572000"/>
+            <a:ext cx="10332720" cy="1371600"/>
+          </a:xfrm>
+          <a:prstGeom prst="rect">
+            <a:avLst/>
+          </a:prstGeom>
+          <a:noFill/>
+        </p:spPr>
+        <p:txBody>
+          <a:bodyPr wrap="square">
+            <a:spAutoFit/>
+          </a:bodyPr>
+          <a:lstStyle/>
+          <a:p>
+            <a:pPr algn="ctr">
+              <a:defRPr sz="4200" b="1">
                 <a:solidFill>
                   <a:srgbClr val="00FFFF"/>
                 </a:solidFill>
@@ -3631,7 +3667,7 @@
     <p:bg>
       <p:bgPr>
         <a:solidFill>
-          <a:srgbClr val="0A0A0A"/>
+          <a:srgbClr val="050505"/>
         </a:solidFill>
         <a:effectLst/>
       </p:bgPr>
@@ -3651,16 +3687,16 @@
         </p:nvSpPr>
         <p:spPr>
           <a:xfrm>
-            <a:off x="10789920" y="274320"/>
-            <a:ext cx="1097280" cy="1097280"/>
+            <a:off x="10881360" y="274320"/>
+            <a:ext cx="1005840" cy="1005840"/>
           </a:xfrm>
           <a:prstGeom prst="ellipse">
             <a:avLst/>
           </a:prstGeom>
           <a:solidFill>
-            <a:srgbClr val="0A0A0A"/>
+            <a:srgbClr val="050505"/>
           </a:solidFill>
-          <a:ln w="38100">
+          <a:ln w="25400">
             <a:solidFill>
               <a:srgbClr val="00FF00"/>
             </a:solidFill>
@@ -3685,7 +3721,7 @@
           <a:lstStyle/>
           <a:p>
             <a:pPr algn="ctr">
-              <a:defRPr sz="2800" b="1">
+              <a:defRPr sz="2600" b="1">
                 <a:solidFill>
                   <a:srgbClr val="00FF00"/>
                 </a:solidFill>
@@ -3705,8 +3741,8 @@
         </p:nvSpPr>
         <p:spPr>
           <a:xfrm>
-            <a:off x="10789920" y="1417320"/>
-            <a:ext cx="1097280" cy="274320"/>
+            <a:off x="10881360" y="1325880"/>
+            <a:ext cx="1005840" cy="274320"/>
           </a:xfrm>
           <a:prstGeom prst="rect">
             <a:avLst/>
@@ -3720,7 +3756,7 @@
           <a:lstStyle/>
           <a:p>
             <a:pPr algn="ctr">
-              <a:defRPr sz="800">
+              <a:defRPr sz="700">
                 <a:solidFill>
                   <a:srgbClr val="00FF00"/>
                 </a:solidFill>
@@ -3775,8 +3811,8 @@
         </p:nvSpPr>
         <p:spPr>
           <a:xfrm>
-            <a:off x="914400" y="1371600"/>
-            <a:ext cx="10362895" cy="1371600"/>
+            <a:off x="914400" y="1828800"/>
+            <a:ext cx="10332720" cy="1371600"/>
           </a:xfrm>
           <a:prstGeom prst="rect">
             <a:avLst/>
@@ -3790,7 +3826,7 @@
           <a:lstStyle/>
           <a:p>
             <a:pPr algn="ctr">
-              <a:defRPr sz="10000" b="1">
+              <a:defRPr sz="6000" b="1">
                 <a:solidFill>
                   <a:srgbClr val="00FF00"/>
                 </a:solidFill>
@@ -3798,7 +3834,7 @@
               </a:defRPr>
             </a:pPr>
             <a:r>
-              <a:t>⬠</a:t>
+              <a:t>⬠ USA</a:t>
             </a:r>
           </a:p>
         </p:txBody>
@@ -3811,8 +3847,8 @@
         </p:nvSpPr>
         <p:spPr>
           <a:xfrm>
-            <a:off x="914400" y="2926080"/>
-            <a:ext cx="10362895" cy="1371600"/>
+            <a:off x="914400" y="3657600"/>
+            <a:ext cx="10332720" cy="1371600"/>
           </a:xfrm>
           <a:prstGeom prst="rect">
             <a:avLst/>
@@ -3826,15 +3862,15 @@
           <a:lstStyle/>
           <a:p>
             <a:pPr algn="ctr">
-              <a:defRPr sz="2800" b="1">
-                <a:solidFill>
-                  <a:srgbClr val="00FF00"/>
+              <a:defRPr sz="4800" b="1">
+                <a:solidFill>
+                  <a:srgbClr val="FF0000"/>
                 </a:solidFill>
                 <a:latin typeface="Courier New"/>
               </a:defRPr>
             </a:pPr>
             <a:r>
-              <a:t>USA</a:t>
+              <a:t>13:00</a:t>
             </a:r>
           </a:p>
         </p:txBody>
@@ -3847,8 +3883,8 @@
         </p:nvSpPr>
         <p:spPr>
           <a:xfrm>
-            <a:off x="914400" y="4114800"/>
-            <a:ext cx="10362895" cy="1371600"/>
+            <a:off x="914400" y="5029200"/>
+            <a:ext cx="10332720" cy="1371600"/>
           </a:xfrm>
           <a:prstGeom prst="rect">
             <a:avLst/>
@@ -3862,7 +3898,7 @@
           <a:lstStyle/>
           <a:p>
             <a:pPr algn="ctr">
-              <a:defRPr sz="5200" b="1">
+              <a:defRPr sz="4000" b="1">
                 <a:solidFill>
                   <a:srgbClr val="FF0000"/>
                 </a:solidFill>
@@ -3870,7 +3906,7 @@
               </a:defRPr>
             </a:pPr>
             <a:r>
-              <a:t>13:00</a:t>
+              <a:t>138</a:t>
             </a:r>
           </a:p>
         </p:txBody>
@@ -3883,8 +3919,8 @@
         </p:nvSpPr>
         <p:spPr>
           <a:xfrm>
-            <a:off x="914400" y="5303520"/>
-            <a:ext cx="10362895" cy="1371600"/>
+            <a:off x="8686800" y="365760"/>
+            <a:ext cx="2743200" cy="914400"/>
           </a:xfrm>
           <a:prstGeom prst="rect">
             <a:avLst/>
@@ -3897,57 +3933,21 @@
           </a:bodyPr>
           <a:lstStyle/>
           <a:p>
-            <a:pPr algn="ctr">
-              <a:defRPr sz="4400" b="1">
-                <a:solidFill>
-                  <a:srgbClr val="FF0000"/>
+            <a:pPr algn="r">
+              <a:defRPr sz="1000">
+                <a:solidFill>
+                  <a:srgbClr val="00FF00"/>
                 </a:solidFill>
                 <a:latin typeface="Courier New"/>
               </a:defRPr>
             </a:pPr>
             <a:r>
-              <a:t>138</a:t>
-            </a:r>
-          </a:p>
-        </p:txBody>
-      </p:sp>
-      <p:sp>
-        <p:nvSpPr>
-          <p:cNvPr id="9" name="TextBox 8"/>
-          <p:cNvSpPr txBox="1"/>
-          <p:nvPr/>
-        </p:nvSpPr>
-        <p:spPr>
-          <a:xfrm>
-            <a:off x="8686800" y="457200"/>
-            <a:ext cx="2743200" cy="914400"/>
-          </a:xfrm>
-          <a:prstGeom prst="rect">
-            <a:avLst/>
-          </a:prstGeom>
-          <a:noFill/>
-        </p:spPr>
-        <p:txBody>
-          <a:bodyPr wrap="square">
-            <a:spAutoFit/>
-          </a:bodyPr>
-          <a:lstStyle/>
+              <a:t>HACK THE PENTAGON</a:t>
+            </a:r>
+          </a:p>
           <a:p>
             <a:pPr algn="r">
-              <a:defRPr sz="1100">
-                <a:solidFill>
-                  <a:srgbClr val="00FF00"/>
-                </a:solidFill>
-                <a:latin typeface="Courier New"/>
-              </a:defRPr>
-            </a:pPr>
-            <a:r>
-              <a:t>HACK THE PENTAGON</a:t>
-            </a:r>
-          </a:p>
-          <a:p>
-            <a:pPr algn="r">
-              <a:defRPr sz="1100">
+              <a:defRPr sz="1000">
                 <a:solidFill>
                   <a:srgbClr val="00FF00"/>
                 </a:solidFill>
@@ -3975,7 +3975,7 @@
     <p:bg>
       <p:bgPr>
         <a:solidFill>
-          <a:srgbClr val="0A0A0A"/>
+          <a:srgbClr val="050505"/>
         </a:solidFill>
         <a:effectLst/>
       </p:bgPr>
@@ -3995,16 +3995,16 @@
         </p:nvSpPr>
         <p:spPr>
           <a:xfrm>
-            <a:off x="10789920" y="274320"/>
-            <a:ext cx="1097280" cy="1097280"/>
+            <a:off x="10881360" y="274320"/>
+            <a:ext cx="1005840" cy="1005840"/>
           </a:xfrm>
           <a:prstGeom prst="ellipse">
             <a:avLst/>
           </a:prstGeom>
           <a:solidFill>
-            <a:srgbClr val="0A0A0A"/>
+            <a:srgbClr val="050505"/>
           </a:solidFill>
-          <a:ln w="38100">
+          <a:ln w="25400">
             <a:solidFill>
               <a:srgbClr val="00FF00"/>
             </a:solidFill>
@@ -4029,7 +4029,7 @@
           <a:lstStyle/>
           <a:p>
             <a:pPr algn="ctr">
-              <a:defRPr sz="2800" b="1">
+              <a:defRPr sz="2600" b="1">
                 <a:solidFill>
                   <a:srgbClr val="00FF00"/>
                 </a:solidFill>
@@ -4049,8 +4049,8 @@
         </p:nvSpPr>
         <p:spPr>
           <a:xfrm>
-            <a:off x="10789920" y="1417320"/>
-            <a:ext cx="1097280" cy="274320"/>
+            <a:off x="10881360" y="1325880"/>
+            <a:ext cx="1005840" cy="274320"/>
           </a:xfrm>
           <a:prstGeom prst="rect">
             <a:avLst/>
@@ -4064,7 +4064,7 @@
           <a:lstStyle/>
           <a:p>
             <a:pPr algn="ctr">
-              <a:defRPr sz="800">
+              <a:defRPr sz="700">
                 <a:solidFill>
                   <a:srgbClr val="00FF00"/>
                 </a:solidFill>
@@ -4119,18 +4119,18 @@
         </p:nvSpPr>
         <p:spPr>
           <a:xfrm>
-            <a:off x="1371600" y="914400"/>
-            <a:ext cx="9144000" cy="5029200"/>
+            <a:off x="1371600" y="731520"/>
+            <a:ext cx="9144000" cy="5303520"/>
           </a:xfrm>
           <a:prstGeom prst="rect">
             <a:avLst/>
           </a:prstGeom>
           <a:solidFill>
-            <a:srgbClr val="0C0C0C"/>
+            <a:srgbClr val="0B0B0B"/>
           </a:solidFill>
-          <a:ln w="12700">
+          <a:ln>
             <a:solidFill>
-              <a:srgbClr val="333333"/>
+              <a:srgbClr val="2A2A2A"/>
             </a:solidFill>
           </a:ln>
         </p:spPr>
@@ -4164,8 +4164,8 @@
         </p:nvSpPr>
         <p:spPr>
           <a:xfrm>
-            <a:off x="1828800" y="1645920"/>
-            <a:ext cx="8229600" cy="4114800"/>
+            <a:off x="1828800" y="1371600"/>
+            <a:ext cx="8229600" cy="4572000"/>
           </a:xfrm>
           <a:prstGeom prst="rect">
             <a:avLst/>
@@ -4179,7 +4179,7 @@
           <a:lstStyle/>
           <a:p>
             <a:pPr>
-              <a:defRPr sz="1300">
+              <a:defRPr sz="1200">
                 <a:solidFill>
                   <a:srgbClr val="00FF00"/>
                 </a:solidFill>
@@ -4192,7 +4192,7 @@
           </a:p>
           <a:p>
             <a:pPr>
-              <a:defRPr sz="1300">
+              <a:defRPr sz="1200">
                 <a:solidFill>
                   <a:srgbClr val="FFFFFF"/>
                 </a:solidFill>
@@ -4205,7 +4205,7 @@
           </a:p>
           <a:p>
             <a:pPr>
-              <a:defRPr sz="1300">
+              <a:defRPr sz="1200">
                 <a:solidFill>
                   <a:srgbClr val="00FF00"/>
                 </a:solidFill>
@@ -4218,7 +4218,7 @@
           </a:p>
           <a:p>
             <a:pPr>
-              <a:defRPr sz="1300">
+              <a:defRPr sz="1200">
                 <a:solidFill>
                   <a:srgbClr val="FFFF00"/>
                 </a:solidFill>
@@ -4231,7 +4231,7 @@
           </a:p>
           <a:p>
             <a:pPr>
-              <a:defRPr sz="1300">
+              <a:defRPr sz="1200">
                 <a:solidFill>
                   <a:srgbClr val="FFFFFF"/>
                 </a:solidFill>
@@ -4244,7 +4244,7 @@
           </a:p>
           <a:p>
             <a:pPr>
-              <a:defRPr sz="1300">
+              <a:defRPr sz="1200">
                 <a:solidFill>
                   <a:srgbClr val="FF0000"/>
                 </a:solidFill>
@@ -4257,7 +4257,7 @@
           </a:p>
           <a:p>
             <a:pPr>
-              <a:defRPr sz="1300">
+              <a:defRPr sz="1200">
                 <a:solidFill>
                   <a:srgbClr val="00FF00"/>
                 </a:solidFill>
@@ -4270,7 +4270,7 @@
           </a:p>
           <a:p>
             <a:pPr>
-              <a:defRPr sz="1300">
+              <a:defRPr sz="1200">
                 <a:solidFill>
                   <a:srgbClr val="FFFFFF"/>
                 </a:solidFill>
@@ -4283,7 +4283,7 @@
           </a:p>
           <a:p>
             <a:pPr>
-              <a:defRPr sz="1300">
+              <a:defRPr sz="1200">
                 <a:solidFill>
                   <a:srgbClr val="00FFFF"/>
                 </a:solidFill>
@@ -4296,7 +4296,7 @@
           </a:p>
           <a:p>
             <a:pPr>
-              <a:defRPr sz="1300">
+              <a:defRPr sz="1200">
                 <a:solidFill>
                   <a:srgbClr val="00FFFF"/>
                 </a:solidFill>
@@ -4324,7 +4324,7 @@
     <p:bg>
       <p:bgPr>
         <a:solidFill>
-          <a:srgbClr val="0A0A0A"/>
+          <a:srgbClr val="050505"/>
         </a:solidFill>
         <a:effectLst/>
       </p:bgPr>
@@ -4344,16 +4344,16 @@
         </p:nvSpPr>
         <p:spPr>
           <a:xfrm>
-            <a:off x="10789920" y="274320"/>
-            <a:ext cx="1097280" cy="1097280"/>
+            <a:off x="10881360" y="274320"/>
+            <a:ext cx="1005840" cy="1005840"/>
           </a:xfrm>
           <a:prstGeom prst="ellipse">
             <a:avLst/>
           </a:prstGeom>
           <a:solidFill>
-            <a:srgbClr val="0A0A0A"/>
+            <a:srgbClr val="050505"/>
           </a:solidFill>
-          <a:ln w="38100">
+          <a:ln w="25400">
             <a:solidFill>
               <a:srgbClr val="00FF00"/>
             </a:solidFill>
@@ -4378,7 +4378,7 @@
           <a:lstStyle/>
           <a:p>
             <a:pPr algn="ctr">
-              <a:defRPr sz="2800" b="1">
+              <a:defRPr sz="2600" b="1">
                 <a:solidFill>
                   <a:srgbClr val="00FF00"/>
                 </a:solidFill>
@@ -4398,8 +4398,8 @@
         </p:nvSpPr>
         <p:spPr>
           <a:xfrm>
-            <a:off x="10789920" y="1417320"/>
-            <a:ext cx="1097280" cy="274320"/>
+            <a:off x="10881360" y="1325880"/>
+            <a:ext cx="1005840" cy="274320"/>
           </a:xfrm>
           <a:prstGeom prst="rect">
             <a:avLst/>
@@ -4413,7 +4413,7 @@
           <a:lstStyle/>
           <a:p>
             <a:pPr algn="ctr">
-              <a:defRPr sz="800">
+              <a:defRPr sz="700">
                 <a:solidFill>
                   <a:srgbClr val="00FF00"/>
                 </a:solidFill>
@@ -4469,7 +4469,7 @@
         <p:spPr>
           <a:xfrm>
             <a:off x="914400" y="274320"/>
-            <a:ext cx="10362895" cy="1371600"/>
+            <a:ext cx="10332720" cy="1371600"/>
           </a:xfrm>
           <a:prstGeom prst="rect">
             <a:avLst/>
@@ -4483,7 +4483,7 @@
           <a:lstStyle/>
           <a:p>
             <a:pPr algn="ctr">
-              <a:defRPr sz="1400" b="0">
+              <a:defRPr sz="1200" b="0">
                 <a:solidFill>
                   <a:srgbClr val="00FF00"/>
                 </a:solidFill>
@@ -4504,8 +4504,8 @@
         </p:nvSpPr>
         <p:spPr>
           <a:xfrm>
-            <a:off x="2743200" y="5029200"/>
-            <a:ext cx="1828800" cy="731520"/>
+            <a:off x="2743200" y="4846320"/>
+            <a:ext cx="1828800" cy="640080"/>
           </a:xfrm>
           <a:prstGeom prst="rect">
             <a:avLst/>
@@ -4519,7 +4519,7 @@
           <a:lstStyle/>
           <a:p>
             <a:pPr algn="ctr">
-              <a:defRPr sz="1400">
+              <a:defRPr sz="1300">
                 <a:solidFill>
                   <a:srgbClr val="00FF00"/>
                 </a:solidFill>
@@ -4540,8 +4540,8 @@
         </p:nvSpPr>
         <p:spPr>
           <a:xfrm>
-            <a:off x="5029200" y="5029200"/>
-            <a:ext cx="1828800" cy="731520"/>
+            <a:off x="5029200" y="4846320"/>
+            <a:ext cx="1828800" cy="640080"/>
           </a:xfrm>
           <a:prstGeom prst="rect">
             <a:avLst/>
@@ -4555,7 +4555,7 @@
           <a:lstStyle/>
           <a:p>
             <a:pPr algn="ctr">
-              <a:defRPr sz="1400">
+              <a:defRPr sz="1300">
                 <a:solidFill>
                   <a:srgbClr val="00FF00"/>
                 </a:solidFill>
@@ -4576,8 +4576,8 @@
         </p:nvSpPr>
         <p:spPr>
           <a:xfrm>
-            <a:off x="7315200" y="5029200"/>
-            <a:ext cx="1828800" cy="731520"/>
+            <a:off x="7315200" y="4846320"/>
+            <a:ext cx="1828800" cy="640080"/>
           </a:xfrm>
           <a:prstGeom prst="rect">
             <a:avLst/>
@@ -4591,7 +4591,7 @@
           <a:lstStyle/>
           <a:p>
             <a:pPr algn="ctr">
-              <a:defRPr sz="1400">
+              <a:defRPr sz="1300">
                 <a:solidFill>
                   <a:srgbClr val="00FF00"/>
                 </a:solidFill>
@@ -4612,8 +4612,8 @@
         </p:nvSpPr>
         <p:spPr>
           <a:xfrm>
-            <a:off x="1828800" y="3200400"/>
-            <a:ext cx="1828800" cy="731520"/>
+            <a:off x="1828800" y="3017520"/>
+            <a:ext cx="1828800" cy="640080"/>
           </a:xfrm>
           <a:prstGeom prst="rect">
             <a:avLst/>
@@ -4627,7 +4627,7 @@
           <a:lstStyle/>
           <a:p>
             <a:pPr algn="ctr">
-              <a:defRPr sz="1400">
+              <a:defRPr sz="1300">
                 <a:solidFill>
                   <a:srgbClr val="00FFFF"/>
                 </a:solidFill>
@@ -4648,8 +4648,8 @@
         </p:nvSpPr>
         <p:spPr>
           <a:xfrm>
-            <a:off x="4114800" y="3200400"/>
-            <a:ext cx="1828800" cy="731520"/>
+            <a:off x="4023360" y="3017520"/>
+            <a:ext cx="1828800" cy="640080"/>
           </a:xfrm>
           <a:prstGeom prst="rect">
             <a:avLst/>
@@ -4663,7 +4663,7 @@
           <a:lstStyle/>
           <a:p>
             <a:pPr algn="ctr">
-              <a:defRPr sz="1400">
+              <a:defRPr sz="1300">
                 <a:solidFill>
                   <a:srgbClr val="00FFFF"/>
                 </a:solidFill>
@@ -4684,8 +4684,8 @@
         </p:nvSpPr>
         <p:spPr>
           <a:xfrm>
-            <a:off x="6400800" y="3200400"/>
-            <a:ext cx="1828800" cy="731520"/>
+            <a:off x="6217920" y="3017520"/>
+            <a:ext cx="1828800" cy="640080"/>
           </a:xfrm>
           <a:prstGeom prst="rect">
             <a:avLst/>
@@ -4699,7 +4699,7 @@
           <a:lstStyle/>
           <a:p>
             <a:pPr algn="ctr">
-              <a:defRPr sz="1400">
+              <a:defRPr sz="1300">
                 <a:solidFill>
                   <a:srgbClr val="00FFFF"/>
                 </a:solidFill>
@@ -4720,8 +4720,8 @@
         </p:nvSpPr>
         <p:spPr>
           <a:xfrm>
-            <a:off x="8686800" y="3200400"/>
-            <a:ext cx="1828800" cy="731520"/>
+            <a:off x="8412480" y="3017520"/>
+            <a:ext cx="1828800" cy="640080"/>
           </a:xfrm>
           <a:prstGeom prst="rect">
             <a:avLst/>
@@ -4735,7 +4735,7 @@
           <a:lstStyle/>
           <a:p>
             <a:pPr algn="ctr">
-              <a:defRPr sz="1400">
+              <a:defRPr sz="1300">
                 <a:solidFill>
                   <a:srgbClr val="00FFFF"/>
                 </a:solidFill>
@@ -4756,8 +4756,8 @@
         </p:nvSpPr>
         <p:spPr>
           <a:xfrm>
-            <a:off x="2743200" y="1371600"/>
-            <a:ext cx="1828800" cy="731520"/>
+            <a:off x="2743200" y="1188720"/>
+            <a:ext cx="1828800" cy="640080"/>
           </a:xfrm>
           <a:prstGeom prst="rect">
             <a:avLst/>
@@ -4771,7 +4771,7 @@
           <a:lstStyle/>
           <a:p>
             <a:pPr algn="ctr">
-              <a:defRPr sz="1400">
+              <a:defRPr sz="1300">
                 <a:solidFill>
                   <a:srgbClr val="FF00FF"/>
                 </a:solidFill>
@@ -4792,8 +4792,8 @@
         </p:nvSpPr>
         <p:spPr>
           <a:xfrm>
-            <a:off x="5029200" y="1371600"/>
-            <a:ext cx="1828800" cy="731520"/>
+            <a:off x="5029200" y="1188720"/>
+            <a:ext cx="1828800" cy="640080"/>
           </a:xfrm>
           <a:prstGeom prst="rect">
             <a:avLst/>
@@ -4807,7 +4807,7 @@
           <a:lstStyle/>
           <a:p>
             <a:pPr algn="ctr">
-              <a:defRPr sz="1400">
+              <a:defRPr sz="1300">
                 <a:solidFill>
                   <a:srgbClr val="FF00FF"/>
                 </a:solidFill>
@@ -4828,8 +4828,8 @@
         </p:nvSpPr>
         <p:spPr>
           <a:xfrm>
-            <a:off x="7315200" y="1371600"/>
-            <a:ext cx="1828800" cy="731520"/>
+            <a:off x="7315200" y="1188720"/>
+            <a:ext cx="1828800" cy="640080"/>
           </a:xfrm>
           <a:prstGeom prst="rect">
             <a:avLst/>
@@ -4843,7 +4843,7 @@
           <a:lstStyle/>
           <a:p>
             <a:pPr algn="ctr">
-              <a:defRPr sz="1400">
+              <a:defRPr sz="1300">
                 <a:solidFill>
                   <a:srgbClr val="FF00FF"/>
                 </a:solidFill>
@@ -4871,7 +4871,7 @@
     <p:bg>
       <p:bgPr>
         <a:solidFill>
-          <a:srgbClr val="0A0A0A"/>
+          <a:srgbClr val="050505"/>
         </a:solidFill>
         <a:effectLst/>
       </p:bgPr>
@@ -4891,16 +4891,16 @@
         </p:nvSpPr>
         <p:spPr>
           <a:xfrm>
-            <a:off x="10789920" y="274320"/>
-            <a:ext cx="1097280" cy="1097280"/>
+            <a:off x="10881360" y="274320"/>
+            <a:ext cx="1005840" cy="1005840"/>
           </a:xfrm>
           <a:prstGeom prst="ellipse">
             <a:avLst/>
           </a:prstGeom>
           <a:solidFill>
-            <a:srgbClr val="0A0A0A"/>
+            <a:srgbClr val="050505"/>
           </a:solidFill>
-          <a:ln w="38100">
+          <a:ln w="25400">
             <a:solidFill>
               <a:srgbClr val="00FF00"/>
             </a:solidFill>
@@ -4925,7 +4925,7 @@
           <a:lstStyle/>
           <a:p>
             <a:pPr algn="ctr">
-              <a:defRPr sz="2800" b="1">
+              <a:defRPr sz="2600" b="1">
                 <a:solidFill>
                   <a:srgbClr val="00FF00"/>
                 </a:solidFill>
@@ -4945,8 +4945,8 @@
         </p:nvSpPr>
         <p:spPr>
           <a:xfrm>
-            <a:off x="10789920" y="1417320"/>
-            <a:ext cx="1097280" cy="274320"/>
+            <a:off x="10881360" y="1325880"/>
+            <a:ext cx="1005840" cy="274320"/>
           </a:xfrm>
           <a:prstGeom prst="rect">
             <a:avLst/>
@@ -4960,7 +4960,7 @@
           <a:lstStyle/>
           <a:p>
             <a:pPr algn="ctr">
-              <a:defRPr sz="800">
+              <a:defRPr sz="700">
                 <a:solidFill>
                   <a:srgbClr val="00FF00"/>
                 </a:solidFill>
@@ -5015,8 +5015,8 @@
         </p:nvSpPr>
         <p:spPr>
           <a:xfrm>
-            <a:off x="457200" y="914400"/>
-            <a:ext cx="5029200" cy="5029200"/>
+            <a:off x="457200" y="731520"/>
+            <a:ext cx="5029200" cy="5486400"/>
           </a:xfrm>
           <a:prstGeom prst="rect">
             <a:avLst/>
@@ -5030,7 +5030,7 @@
           <a:lstStyle/>
           <a:p>
             <a:pPr algn="ctr">
-              <a:defRPr sz="4800">
+              <a:defRPr sz="4400">
                 <a:solidFill>
                   <a:srgbClr val="FF0000"/>
                 </a:solidFill>
@@ -5043,7 +5043,7 @@
           </a:p>
           <a:p>
             <a:pPr algn="ctr">
-              <a:defRPr sz="1600">
+              <a:defRPr sz="1500">
                 <a:solidFill>
                   <a:srgbClr val="FF0000"/>
                 </a:solidFill>
@@ -5053,7 +5053,7 @@
           </a:p>
           <a:p>
             <a:pPr algn="ctr">
-              <a:defRPr sz="1600">
+              <a:defRPr sz="1500">
                 <a:solidFill>
                   <a:srgbClr val="FF0000"/>
                 </a:solidFill>
@@ -5066,7 +5066,7 @@
           </a:p>
           <a:p>
             <a:pPr algn="ctr">
-              <a:defRPr sz="1600">
+              <a:defRPr sz="1500">
                 <a:solidFill>
                   <a:srgbClr val="FF0000"/>
                 </a:solidFill>
@@ -5079,7 +5079,7 @@
           </a:p>
           <a:p>
             <a:pPr algn="ctr">
-              <a:defRPr sz="1600">
+              <a:defRPr sz="1500">
                 <a:solidFill>
                   <a:srgbClr val="FF0000"/>
                 </a:solidFill>
@@ -5092,7 +5092,7 @@
           </a:p>
           <a:p>
             <a:pPr algn="ctr">
-              <a:defRPr sz="1600">
+              <a:defRPr sz="1500">
                 <a:solidFill>
                   <a:srgbClr val="FF0000"/>
                 </a:solidFill>
@@ -5113,8 +5113,8 @@
         </p:nvSpPr>
         <p:spPr>
           <a:xfrm>
-            <a:off x="6400800" y="914400"/>
-            <a:ext cx="5029200" cy="5029200"/>
+            <a:off x="6400800" y="731520"/>
+            <a:ext cx="5029200" cy="5486400"/>
           </a:xfrm>
           <a:prstGeom prst="rect">
             <a:avLst/>
@@ -5128,7 +5128,7 @@
           <a:lstStyle/>
           <a:p>
             <a:pPr algn="ctr">
-              <a:defRPr sz="4800">
+              <a:defRPr sz="4400">
                 <a:solidFill>
                   <a:srgbClr val="00FF00"/>
                 </a:solidFill>
@@ -5141,7 +5141,7 @@
           </a:p>
           <a:p>
             <a:pPr algn="ctr">
-              <a:defRPr sz="1600">
+              <a:defRPr sz="1500">
                 <a:solidFill>
                   <a:srgbClr val="00FF00"/>
                 </a:solidFill>
@@ -5151,7 +5151,7 @@
           </a:p>
           <a:p>
             <a:pPr algn="ctr">
-              <a:defRPr sz="1600">
+              <a:defRPr sz="1500">
                 <a:solidFill>
                   <a:srgbClr val="00FF00"/>
                 </a:solidFill>
@@ -5164,7 +5164,7 @@
           </a:p>
           <a:p>
             <a:pPr algn="ctr">
-              <a:defRPr sz="1600">
+              <a:defRPr sz="1500">
                 <a:solidFill>
                   <a:srgbClr val="00FF00"/>
                 </a:solidFill>
@@ -5177,7 +5177,7 @@
           </a:p>
           <a:p>
             <a:pPr algn="ctr">
-              <a:defRPr sz="1600">
+              <a:defRPr sz="1500">
                 <a:solidFill>
                   <a:srgbClr val="00FF00"/>
                 </a:solidFill>
@@ -5190,7 +5190,7 @@
           </a:p>
           <a:p>
             <a:pPr algn="ctr">
-              <a:defRPr sz="1600">
+              <a:defRPr sz="1500">
                 <a:solidFill>
                   <a:srgbClr val="00FF00"/>
                 </a:solidFill>
@@ -5212,13 +5212,13 @@
         <p:spPr>
           <a:xfrm>
             <a:off x="5852160" y="457200"/>
-            <a:ext cx="45720" cy="5943600"/>
+            <a:ext cx="36576" cy="5943600"/>
           </a:xfrm>
           <a:prstGeom prst="rect">
             <a:avLst/>
           </a:prstGeom>
           <a:solidFill>
-            <a:srgbClr val="555555"/>
+            <a:srgbClr val="444444"/>
           </a:solidFill>
           <a:ln>
             <a:noFill/>

</xml_diff>